<commit_message>
Updated to Nested CV & Moved Preprocessing to CV folds
</commit_message>
<xml_diff>
--- a/kaysonyao/04_results_and_figures/presentation/DP3_Pipeline_Onboarding.pptx
+++ b/kaysonyao/04_results_and_figures/presentation/DP3_Pipeline_Onboarding.pptx
@@ -7340,7 +7340,7 @@
         <p:spPr>
           <a:xfrm>
             <a:off x="320040" y="960120"/>
-            <a:ext cx="4114800" cy="4023360"/>
+            <a:ext cx="4114800" cy="2258569"/>
           </a:xfrm>
           <a:prstGeom prst="rect">
             <a:avLst/>
@@ -7483,7 +7483,7 @@
         <p:spPr>
           <a:xfrm>
             <a:off x="4617720" y="960120"/>
-            <a:ext cx="4114800" cy="4023360"/>
+            <a:ext cx="4114800" cy="2350004"/>
           </a:xfrm>
           <a:prstGeom prst="rect">
             <a:avLst/>
@@ -9576,8 +9576,8 @@
         </p:nvSpPr>
         <p:spPr>
           <a:xfrm>
-            <a:off x="320040" y="960120"/>
-            <a:ext cx="4114800" cy="4023360"/>
+            <a:off x="320040" y="960121"/>
+            <a:ext cx="4114800" cy="2350004"/>
           </a:xfrm>
           <a:prstGeom prst="rect">
             <a:avLst/>
@@ -9720,7 +9720,7 @@
         <p:spPr>
           <a:xfrm>
             <a:off x="4617720" y="960120"/>
-            <a:ext cx="4114800" cy="4023360"/>
+            <a:ext cx="4114800" cy="2350005"/>
           </a:xfrm>
           <a:prstGeom prst="rect">
             <a:avLst/>
@@ -10028,7 +10028,7 @@
                 <a:ea typeface="Calibri" pitchFamily="34" charset="-122"/>
                 <a:cs typeface="Calibri" pitchFamily="34" charset="-120"/>
               </a:rPr>
-              <a:t>Mann-Whitney U: Control vs FGR, Control vs HDP, Control vs sPTB</a:t>
+              <a:t>KS Test: Control vs FGR, Control vs HDP, Control vs sPTB</a:t>
             </a:r>
             <a:endParaRPr lang="en-US" sz="1100" dirty="0"/>
           </a:p>
@@ -10070,7 +10070,7 @@
                 <a:ea typeface="Calibri" pitchFamily="34" charset="-122"/>
                 <a:cs typeface="Calibri" pitchFamily="34" charset="-120"/>
               </a:rPr>
-              <a:t>BH FDR applied within each survey × visit</a:t>
+              <a:t>KS test applied within each survey × visit</a:t>
             </a:r>
             <a:endParaRPr lang="en-US" sz="1100" dirty="0"/>
           </a:p>
@@ -21290,7 +21290,27 @@
               </a:rPr>
               <a:t>MetaboAnalyst</a:t>
             </a:r>
-            <a:endParaRPr lang="en-US" sz="1100" dirty="0"/>
+            <a:r>
+              <a:rPr lang="en-US" sz="1100" b="1" dirty="0">
+                <a:solidFill>
+                  <a:srgbClr val="FFFFFF"/>
+                </a:solidFill>
+              </a:rPr>
+              <a:t> &amp; </a:t>
+            </a:r>
+            <a:r>
+              <a:rPr lang="en-US" sz="1100" b="1" dirty="0">
+                <a:solidFill>
+                  <a:srgbClr val="FF0000"/>
+                </a:solidFill>
+              </a:rPr>
+              <a:t>Check Step 34</a:t>
+            </a:r>
+            <a:endParaRPr lang="en-US" sz="1100" dirty="0">
+              <a:solidFill>
+                <a:srgbClr val="FF0000"/>
+              </a:solidFill>
+            </a:endParaRPr>
           </a:p>
         </p:txBody>
       </p:sp>

</xml_diff>